<commit_message>
docs: refresh deck, PowerPoint and user guide for the Counter till redesign
</commit_message>
<xml_diff>
--- a/docs/Hairline Salon Manager - Presentation.pptx
+++ b/docs/Hairline Salon Manager - Presentation.pptx
@@ -3847,7 +3847,7 @@
         <p:spPr>
           <a:xfrm>
             <a:off x="4572000" y="2286000"/>
-            <a:ext cx="6766560" cy="3825197"/>
+            <a:ext cx="6766560" cy="4300377"/>
           </a:xfrm>
           <a:prstGeom prst="rect">
             <a:avLst/>
@@ -3863,7 +3863,7 @@
         <p:spPr>
           <a:xfrm>
             <a:off x="4572000" y="2286000"/>
-            <a:ext cx="6766560" cy="3825197"/>
+            <a:ext cx="6766560" cy="4300377"/>
           </a:xfrm>
           <a:prstGeom prst="rect">
             <a:avLst/>
@@ -4474,7 +4474,7 @@
         <p:spPr>
           <a:xfrm>
             <a:off x="987552" y="2450592"/>
-            <a:ext cx="3072384" cy="1736846"/>
+            <a:ext cx="3072384" cy="1952604"/>
           </a:xfrm>
           <a:prstGeom prst="rect">
             <a:avLst/>
@@ -4490,7 +4490,7 @@
         <p:spPr>
           <a:xfrm>
             <a:off x="987552" y="2450592"/>
-            <a:ext cx="3072384" cy="1736846"/>
+            <a:ext cx="3072384" cy="1952604"/>
           </a:xfrm>
           <a:prstGeom prst="rect">
             <a:avLst/>
@@ -4664,7 +4664,7 @@
         <p:spPr>
           <a:xfrm>
             <a:off x="4599432" y="2450592"/>
-            <a:ext cx="3072384" cy="1736846"/>
+            <a:ext cx="3072384" cy="1952604"/>
           </a:xfrm>
           <a:prstGeom prst="rect">
             <a:avLst/>
@@ -4680,7 +4680,7 @@
         <p:spPr>
           <a:xfrm>
             <a:off x="4599432" y="2450592"/>
-            <a:ext cx="3072384" cy="1736846"/>
+            <a:ext cx="3072384" cy="1952604"/>
           </a:xfrm>
           <a:prstGeom prst="rect">
             <a:avLst/>
@@ -4854,7 +4854,7 @@
         <p:spPr>
           <a:xfrm>
             <a:off x="8211312" y="2450592"/>
-            <a:ext cx="3072384" cy="1736846"/>
+            <a:ext cx="3072384" cy="1952604"/>
           </a:xfrm>
           <a:prstGeom prst="rect">
             <a:avLst/>
@@ -4870,7 +4870,7 @@
         <p:spPr>
           <a:xfrm>
             <a:off x="8211312" y="2450592"/>
-            <a:ext cx="3072384" cy="1736846"/>
+            <a:ext cx="3072384" cy="1952604"/>
           </a:xfrm>
           <a:prstGeom prst="rect">
             <a:avLst/>
@@ -13483,7 +13483,7 @@
         <p:spPr>
           <a:xfrm>
             <a:off x="6400800" y="1371600"/>
-            <a:ext cx="4937760" cy="2791360"/>
+            <a:ext cx="4937760" cy="3138113"/>
           </a:xfrm>
           <a:prstGeom prst="rect">
             <a:avLst/>
@@ -13499,7 +13499,7 @@
         <p:spPr>
           <a:xfrm>
             <a:off x="6400800" y="1371600"/>
-            <a:ext cx="4937760" cy="2791360"/>
+            <a:ext cx="4937760" cy="3138113"/>
           </a:xfrm>
           <a:prstGeom prst="rect">
             <a:avLst/>
@@ -13785,7 +13785,7 @@
         <p:spPr>
           <a:xfrm>
             <a:off x="822960" y="2286000"/>
-            <a:ext cx="6675120" cy="3773505"/>
+            <a:ext cx="6675120" cy="4242264"/>
           </a:xfrm>
           <a:prstGeom prst="rect">
             <a:avLst/>
@@ -13801,7 +13801,7 @@
         <p:spPr>
           <a:xfrm>
             <a:off x="822960" y="2286000"/>
-            <a:ext cx="6675120" cy="3773505"/>
+            <a:ext cx="6675120" cy="4242264"/>
           </a:xfrm>
           <a:prstGeom prst="rect">
             <a:avLst/>
@@ -13882,7 +13882,7 @@
                 </a:solidFill>
                 <a:latin typeface="Segoe UI"/>
               </a:rPr>
-              <a:t>One screen:</a:t>
+              <a:t>One search</a:t>
             </a:r>
             <a:r>
               <a:rPr sz="1200">
@@ -13891,7 +13891,7 @@
                 </a:solidFill>
                 <a:latin typeface="Segoe UI"/>
               </a:rPr>
-              <a:t> client, services, products, discount, payment.</a:t>
+              <a:t> finds a client, a service or a scanned barcode.</a:t>
             </a:r>
           </a:p>
           <a:p>
@@ -13919,7 +13919,7 @@
                 </a:solidFill>
                 <a:latin typeface="Segoe UI"/>
               </a:rPr>
-              <a:t>Split payments</a:t>
+              <a:t>Big tappable tiles</a:t>
             </a:r>
             <a:r>
               <a:rPr sz="1200">
@@ -13928,7 +13928,7 @@
                 </a:solidFill>
                 <a:latin typeface="Segoe UI"/>
               </a:rPr>
-              <a:t> across cash, card, EFT and vouchers.</a:t>
+              <a:t> — laid out for a counter, not a desk.</a:t>
             </a:r>
           </a:p>
           <a:p>
@@ -13956,7 +13956,7 @@
                 </a:solidFill>
                 <a:latin typeface="Segoe UI"/>
               </a:rPr>
-              <a:t>Tips per stylist,</a:t>
+              <a:t>The balance owing</a:t>
             </a:r>
             <a:r>
               <a:rPr sz="1200">
@@ -13965,7 +13965,7 @@
                 </a:solidFill>
                 <a:latin typeface="Segoe UI"/>
               </a:rPr>
-              <a:t> captured at the moment of payment.</a:t>
+              <a:t> is the largest thing on screen, with a keypad beneath it.</a:t>
             </a:r>
           </a:p>
           <a:p>
@@ -14002,7 +14002,7 @@
                 </a:solidFill>
                 <a:latin typeface="Segoe UI"/>
               </a:rPr>
-              <a:t> makes the 30-second target visible.</a:t>
+              <a:t> keeps the 30-second target honest.</a:t>
             </a:r>
           </a:p>
         </p:txBody>

</xml_diff>

<commit_message>
feat: till lists ordered by usage, vendor tabs for retail, tips charged to the client
</commit_message>
<xml_diff>
--- a/docs/Hairline Salon Manager - Presentation.pptx
+++ b/docs/Hairline Salon Manager - Presentation.pptx
@@ -19,6 +19,7 @@
     <p:sldId id="267" r:id="rId18"/>
     <p:sldId id="268" r:id="rId19"/>
     <p:sldId id="269" r:id="rId20"/>
+    <p:sldId id="270" r:id="rId21"/>
   </p:sldIdLst>
   <p:sldSz cx="12191695" cy="6858000" type="screen4x3"/>
   <p:notesSz cx="6858000" cy="9144000"/>
@@ -6697,6 +6698,1147 @@
                 </a:solidFill>
                 <a:latin typeface="Segoe UI"/>
               </a:rPr>
+              <a:t>WHAT IT COSTS TO RUN</a:t>
+            </a:r>
+          </a:p>
+        </p:txBody>
+      </p:sp>
+      <p:sp>
+        <p:nvSpPr>
+          <p:cNvPr id="5" name="TextBox 4"/>
+          <p:cNvSpPr txBox="1"/>
+          <p:nvPr/>
+        </p:nvSpPr>
+        <p:spPr>
+          <a:xfrm>
+            <a:off x="822960" y="1371600"/>
+            <a:ext cx="9601200" cy="1188720"/>
+          </a:xfrm>
+          <a:prstGeom prst="rect">
+            <a:avLst/>
+          </a:prstGeom>
+          <a:noFill/>
+        </p:spPr>
+        <p:txBody>
+          <a:bodyPr wrap="square" anchor="t" lIns="0" rIns="0" tIns="0" bIns="0">
+            <a:spAutoFit/>
+          </a:bodyPr>
+          <a:lstStyle/>
+          <a:p>
+            <a:pPr algn="l">
+              <a:lnSpc>
+                <a:spcPct val="105000"/>
+              </a:lnSpc>
+              <a:spcAft>
+                <a:spcPts val="0"/>
+              </a:spcAft>
+            </a:pPr>
+            <a:r>
+              <a:rPr sz="3000" b="0">
+                <a:solidFill>
+                  <a:srgbClr val="1A1816"/>
+                </a:solidFill>
+                <a:latin typeface="Segoe UI Light"/>
+              </a:rPr>
+              <a:t>Hosting and the database, at a glance.</a:t>
+            </a:r>
+          </a:p>
+        </p:txBody>
+      </p:sp>
+      <p:sp>
+        <p:nvSpPr>
+          <p:cNvPr id="6" name="TextBox 5"/>
+          <p:cNvSpPr txBox="1"/>
+          <p:nvPr/>
+        </p:nvSpPr>
+        <p:spPr>
+          <a:xfrm>
+            <a:off x="822960" y="2514600"/>
+            <a:ext cx="5760720" cy="3291840"/>
+          </a:xfrm>
+          <a:prstGeom prst="rect">
+            <a:avLst/>
+          </a:prstGeom>
+          <a:noFill/>
+        </p:spPr>
+        <p:txBody>
+          <a:bodyPr wrap="square" anchor="t" lIns="0" rIns="0" tIns="0" bIns="0">
+            <a:spAutoFit/>
+          </a:bodyPr>
+          <a:lstStyle/>
+          <a:p>
+            <a:pPr>
+              <a:lnSpc>
+                <a:spcPct val="128000"/>
+              </a:lnSpc>
+              <a:spcAft>
+                <a:spcPts val="1200"/>
+              </a:spcAft>
+            </a:pPr>
+            <a:r>
+              <a:rPr sz="1350">
+                <a:solidFill>
+                  <a:srgbClr val="8A7F6F"/>
+                </a:solidFill>
+                <a:latin typeface="Segoe UI"/>
+              </a:rPr>
+              <a:t>—   </a:t>
+            </a:r>
+            <a:r>
+              <a:rPr sz="1350" b="1">
+                <a:solidFill>
+                  <a:srgbClr val="1A1816"/>
+                </a:solidFill>
+                <a:latin typeface="Segoe UI"/>
+              </a:rPr>
+              <a:t>Hosting (Vercel).</a:t>
+            </a:r>
+            <a:r>
+              <a:rPr sz="1350">
+                <a:solidFill>
+                  <a:srgbClr val="3A362F"/>
+                </a:solidFill>
+                <a:latin typeface="Segoe UI"/>
+              </a:rPr>
+              <a:t> Pro plan, $20 per user a month (≈R380) — the free tier is personal-use only, and a trading salon needs Pro.</a:t>
+            </a:r>
+          </a:p>
+          <a:p>
+            <a:pPr>
+              <a:lnSpc>
+                <a:spcPct val="128000"/>
+              </a:lnSpc>
+              <a:spcAft>
+                <a:spcPts val="1200"/>
+              </a:spcAft>
+            </a:pPr>
+            <a:r>
+              <a:rPr sz="1350">
+                <a:solidFill>
+                  <a:srgbClr val="8A7F6F"/>
+                </a:solidFill>
+                <a:latin typeface="Segoe UI"/>
+              </a:rPr>
+              <a:t>—   </a:t>
+            </a:r>
+            <a:r>
+              <a:rPr sz="1350" b="1">
+                <a:solidFill>
+                  <a:srgbClr val="1A1816"/>
+                </a:solidFill>
+                <a:latin typeface="Segoe UI"/>
+              </a:rPr>
+              <a:t>Database (Neon Postgres).</a:t>
+            </a:r>
+            <a:r>
+              <a:rPr sz="1350">
+                <a:solidFill>
+                  <a:srgbClr val="3A362F"/>
+                </a:solidFill>
+                <a:latin typeface="Segoe UI"/>
+              </a:rPr>
+              <a:t> Free tier — 0.5GB storage, 100 compute-hours a month — comfortably covers Hairline's data; usage-based only if outgrown.</a:t>
+            </a:r>
+          </a:p>
+          <a:p>
+            <a:pPr>
+              <a:lnSpc>
+                <a:spcPct val="128000"/>
+              </a:lnSpc>
+              <a:spcAft>
+                <a:spcPts val="1200"/>
+              </a:spcAft>
+            </a:pPr>
+            <a:r>
+              <a:rPr sz="1350">
+                <a:solidFill>
+                  <a:srgbClr val="8A7F6F"/>
+                </a:solidFill>
+                <a:latin typeface="Segoe UI"/>
+              </a:rPr>
+              <a:t>—   </a:t>
+            </a:r>
+            <a:r>
+              <a:rPr sz="1350" b="1">
+                <a:solidFill>
+                  <a:srgbClr val="1A1816"/>
+                </a:solidFill>
+                <a:latin typeface="Segoe UI"/>
+              </a:rPr>
+              <a:t>Card machine.</a:t>
+            </a:r>
+            <a:r>
+              <a:rPr sz="1350">
+                <a:solidFill>
+                  <a:srgbClr val="3A362F"/>
+                </a:solidFill>
+                <a:latin typeface="Segoe UI"/>
+              </a:rPr>
+              <a:t> No change and no new cost — the standalone terminal stays exactly as it is today.</a:t>
+            </a:r>
+          </a:p>
+          <a:p>
+            <a:pPr>
+              <a:lnSpc>
+                <a:spcPct val="128000"/>
+              </a:lnSpc>
+              <a:spcAft>
+                <a:spcPts val="1200"/>
+              </a:spcAft>
+            </a:pPr>
+            <a:r>
+              <a:rPr sz="1350">
+                <a:solidFill>
+                  <a:srgbClr val="8A7F6F"/>
+                </a:solidFill>
+                <a:latin typeface="Segoe UI"/>
+              </a:rPr>
+              <a:t>—   </a:t>
+            </a:r>
+            <a:r>
+              <a:rPr sz="1350" b="1">
+                <a:solidFill>
+                  <a:srgbClr val="1A1816"/>
+                </a:solidFill>
+                <a:latin typeface="Segoe UI"/>
+              </a:rPr>
+              <a:t>Messaging (SMS/WhatsApp).</a:t>
+            </a:r>
+            <a:r>
+              <a:rPr sz="1350">
+                <a:solidFill>
+                  <a:srgbClr val="3A362F"/>
+                </a:solidFill>
+                <a:latin typeface="Segoe UI"/>
+              </a:rPr>
+              <a:t> Billed per message sent, separately from hosting.</a:t>
+            </a:r>
+          </a:p>
+        </p:txBody>
+      </p:sp>
+      <p:sp>
+        <p:nvSpPr>
+          <p:cNvPr id="7" name="Rounded Rectangle 6"/>
+          <p:cNvSpPr/>
+          <p:nvPr/>
+        </p:nvSpPr>
+        <p:spPr>
+          <a:xfrm>
+            <a:off x="6949440" y="2331720"/>
+            <a:ext cx="4434840" cy="3063240"/>
+          </a:xfrm>
+          <a:prstGeom prst="roundRect">
+            <a:avLst>
+              <a:gd name="adj" fmla="val 3000"/>
+            </a:avLst>
+          </a:prstGeom>
+          <a:solidFill>
+            <a:srgbClr val="FFFFFF"/>
+          </a:solidFill>
+          <a:ln w="9525">
+            <a:solidFill>
+              <a:srgbClr val="E2DED7"/>
+            </a:solidFill>
+          </a:ln>
+          <a:effectLst/>
+        </p:spPr>
+        <p:style>
+          <a:lnRef idx="1">
+            <a:schemeClr val="accent1"/>
+          </a:lnRef>
+          <a:fillRef idx="3">
+            <a:schemeClr val="accent1"/>
+          </a:fillRef>
+          <a:effectRef idx="2">
+            <a:schemeClr val="accent1"/>
+          </a:effectRef>
+          <a:fontRef idx="minor">
+            <a:schemeClr val="lt1"/>
+          </a:fontRef>
+        </p:style>
+        <p:txBody>
+          <a:bodyPr rtlCol="0" anchor="ctr"/>
+          <a:lstStyle/>
+          <a:p>
+            <a:pPr algn="ctr"/>
+          </a:p>
+        </p:txBody>
+      </p:sp>
+      <p:sp>
+        <p:nvSpPr>
+          <p:cNvPr id="8" name="TextBox 7"/>
+          <p:cNvSpPr txBox="1"/>
+          <p:nvPr/>
+        </p:nvSpPr>
+        <p:spPr>
+          <a:xfrm>
+            <a:off x="7269480" y="2560320"/>
+            <a:ext cx="3794760" cy="274320"/>
+          </a:xfrm>
+          <a:prstGeom prst="rect">
+            <a:avLst/>
+          </a:prstGeom>
+          <a:noFill/>
+        </p:spPr>
+        <p:txBody>
+          <a:bodyPr wrap="square" anchor="t" lIns="0" rIns="0" tIns="0" bIns="0">
+            <a:spAutoFit/>
+          </a:bodyPr>
+          <a:lstStyle/>
+          <a:p>
+            <a:pPr algn="l">
+              <a:spcAft>
+                <a:spcPts val="0"/>
+              </a:spcAft>
+            </a:pPr>
+            <a:r>
+              <a:rPr sz="950" b="1" spc="120">
+                <a:solidFill>
+                  <a:srgbClr val="8A7F6F"/>
+                </a:solidFill>
+                <a:latin typeface="Segoe UI"/>
+              </a:rPr>
+              <a:t>TYPICAL MONTHLY COST</a:t>
+            </a:r>
+          </a:p>
+        </p:txBody>
+      </p:sp>
+      <p:sp>
+        <p:nvSpPr>
+          <p:cNvPr id="9" name="Rectangle 8"/>
+          <p:cNvSpPr/>
+          <p:nvPr/>
+        </p:nvSpPr>
+        <p:spPr>
+          <a:xfrm>
+            <a:off x="7269480" y="2834640"/>
+            <a:ext cx="3794760" cy="9525"/>
+          </a:xfrm>
+          <a:prstGeom prst="rect">
+            <a:avLst/>
+          </a:prstGeom>
+          <a:solidFill>
+            <a:srgbClr val="8A7F6F"/>
+          </a:solidFill>
+          <a:ln>
+            <a:noFill/>
+          </a:ln>
+          <a:effectLst/>
+        </p:spPr>
+        <p:style>
+          <a:lnRef idx="1">
+            <a:schemeClr val="accent1"/>
+          </a:lnRef>
+          <a:fillRef idx="3">
+            <a:schemeClr val="accent1"/>
+          </a:fillRef>
+          <a:effectRef idx="2">
+            <a:schemeClr val="accent1"/>
+          </a:effectRef>
+          <a:fontRef idx="minor">
+            <a:schemeClr val="lt1"/>
+          </a:fontRef>
+        </p:style>
+        <p:txBody>
+          <a:bodyPr rtlCol="0" anchor="ctr"/>
+          <a:lstStyle/>
+          <a:p>
+            <a:pPr algn="ctr"/>
+          </a:p>
+        </p:txBody>
+      </p:sp>
+      <p:sp>
+        <p:nvSpPr>
+          <p:cNvPr id="10" name="TextBox 9"/>
+          <p:cNvSpPr txBox="1"/>
+          <p:nvPr/>
+        </p:nvSpPr>
+        <p:spPr>
+          <a:xfrm>
+            <a:off x="7269480" y="2971800"/>
+            <a:ext cx="2103120" cy="310896"/>
+          </a:xfrm>
+          <a:prstGeom prst="rect">
+            <a:avLst/>
+          </a:prstGeom>
+          <a:noFill/>
+        </p:spPr>
+        <p:txBody>
+          <a:bodyPr wrap="square" anchor="t" lIns="0" rIns="0" tIns="0" bIns="0">
+            <a:spAutoFit/>
+          </a:bodyPr>
+          <a:lstStyle/>
+          <a:p>
+            <a:pPr algn="l">
+              <a:spcAft>
+                <a:spcPts val="0"/>
+              </a:spcAft>
+            </a:pPr>
+            <a:r>
+              <a:rPr sz="1200" b="0">
+                <a:solidFill>
+                  <a:srgbClr val="1A1816"/>
+                </a:solidFill>
+                <a:latin typeface="Segoe UI"/>
+              </a:rPr>
+              <a:t>Hosting — Vercel Pro</a:t>
+            </a:r>
+          </a:p>
+        </p:txBody>
+      </p:sp>
+      <p:sp>
+        <p:nvSpPr>
+          <p:cNvPr id="11" name="TextBox 10"/>
+          <p:cNvSpPr txBox="1"/>
+          <p:nvPr/>
+        </p:nvSpPr>
+        <p:spPr>
+          <a:xfrm>
+            <a:off x="9372600" y="2971800"/>
+            <a:ext cx="1691640" cy="310896"/>
+          </a:xfrm>
+          <a:prstGeom prst="rect">
+            <a:avLst/>
+          </a:prstGeom>
+          <a:noFill/>
+        </p:spPr>
+        <p:txBody>
+          <a:bodyPr wrap="square" anchor="t" lIns="0" rIns="0" tIns="0" bIns="0">
+            <a:spAutoFit/>
+          </a:bodyPr>
+          <a:lstStyle/>
+          <a:p>
+            <a:pPr algn="r">
+              <a:spcAft>
+                <a:spcPts val="0"/>
+              </a:spcAft>
+            </a:pPr>
+            <a:r>
+              <a:rPr sz="1200" b="0">
+                <a:solidFill>
+                  <a:srgbClr val="7A7264"/>
+                </a:solidFill>
+                <a:latin typeface="Segoe UI"/>
+              </a:rPr>
+              <a:t>≈ R380</a:t>
+            </a:r>
+          </a:p>
+        </p:txBody>
+      </p:sp>
+      <p:sp>
+        <p:nvSpPr>
+          <p:cNvPr id="12" name="Rectangle 11"/>
+          <p:cNvSpPr/>
+          <p:nvPr/>
+        </p:nvSpPr>
+        <p:spPr>
+          <a:xfrm>
+            <a:off x="7269480" y="3300984"/>
+            <a:ext cx="3794760" cy="9525"/>
+          </a:xfrm>
+          <a:prstGeom prst="rect">
+            <a:avLst/>
+          </a:prstGeom>
+          <a:solidFill>
+            <a:srgbClr val="EDEAE4"/>
+          </a:solidFill>
+          <a:ln>
+            <a:noFill/>
+          </a:ln>
+          <a:effectLst/>
+        </p:spPr>
+        <p:style>
+          <a:lnRef idx="1">
+            <a:schemeClr val="accent1"/>
+          </a:lnRef>
+          <a:fillRef idx="3">
+            <a:schemeClr val="accent1"/>
+          </a:fillRef>
+          <a:effectRef idx="2">
+            <a:schemeClr val="accent1"/>
+          </a:effectRef>
+          <a:fontRef idx="minor">
+            <a:schemeClr val="lt1"/>
+          </a:fontRef>
+        </p:style>
+        <p:txBody>
+          <a:bodyPr rtlCol="0" anchor="ctr"/>
+          <a:lstStyle/>
+          <a:p>
+            <a:pPr algn="ctr"/>
+          </a:p>
+        </p:txBody>
+      </p:sp>
+      <p:sp>
+        <p:nvSpPr>
+          <p:cNvPr id="13" name="TextBox 12"/>
+          <p:cNvSpPr txBox="1"/>
+          <p:nvPr/>
+        </p:nvSpPr>
+        <p:spPr>
+          <a:xfrm>
+            <a:off x="7269480" y="3392424"/>
+            <a:ext cx="2103120" cy="310896"/>
+          </a:xfrm>
+          <a:prstGeom prst="rect">
+            <a:avLst/>
+          </a:prstGeom>
+          <a:noFill/>
+        </p:spPr>
+        <p:txBody>
+          <a:bodyPr wrap="square" anchor="t" lIns="0" rIns="0" tIns="0" bIns="0">
+            <a:spAutoFit/>
+          </a:bodyPr>
+          <a:lstStyle/>
+          <a:p>
+            <a:pPr algn="l">
+              <a:spcAft>
+                <a:spcPts val="0"/>
+              </a:spcAft>
+            </a:pPr>
+            <a:r>
+              <a:rPr sz="1200" b="0">
+                <a:solidFill>
+                  <a:srgbClr val="1A1816"/>
+                </a:solidFill>
+                <a:latin typeface="Segoe UI"/>
+              </a:rPr>
+              <a:t>Database — Neon</a:t>
+            </a:r>
+          </a:p>
+        </p:txBody>
+      </p:sp>
+      <p:sp>
+        <p:nvSpPr>
+          <p:cNvPr id="14" name="TextBox 13"/>
+          <p:cNvSpPr txBox="1"/>
+          <p:nvPr/>
+        </p:nvSpPr>
+        <p:spPr>
+          <a:xfrm>
+            <a:off x="9372600" y="3392424"/>
+            <a:ext cx="1691640" cy="310896"/>
+          </a:xfrm>
+          <a:prstGeom prst="rect">
+            <a:avLst/>
+          </a:prstGeom>
+          <a:noFill/>
+        </p:spPr>
+        <p:txBody>
+          <a:bodyPr wrap="square" anchor="t" lIns="0" rIns="0" tIns="0" bIns="0">
+            <a:spAutoFit/>
+          </a:bodyPr>
+          <a:lstStyle/>
+          <a:p>
+            <a:pPr algn="r">
+              <a:spcAft>
+                <a:spcPts val="0"/>
+              </a:spcAft>
+            </a:pPr>
+            <a:r>
+              <a:rPr sz="1200" b="0">
+                <a:solidFill>
+                  <a:srgbClr val="7A7264"/>
+                </a:solidFill>
+                <a:latin typeface="Segoe UI"/>
+              </a:rPr>
+              <a:t>R0 in free tier</a:t>
+            </a:r>
+          </a:p>
+        </p:txBody>
+      </p:sp>
+      <p:sp>
+        <p:nvSpPr>
+          <p:cNvPr id="15" name="Rectangle 14"/>
+          <p:cNvSpPr/>
+          <p:nvPr/>
+        </p:nvSpPr>
+        <p:spPr>
+          <a:xfrm>
+            <a:off x="7269480" y="3721608"/>
+            <a:ext cx="3794760" cy="9525"/>
+          </a:xfrm>
+          <a:prstGeom prst="rect">
+            <a:avLst/>
+          </a:prstGeom>
+          <a:solidFill>
+            <a:srgbClr val="EDEAE4"/>
+          </a:solidFill>
+          <a:ln>
+            <a:noFill/>
+          </a:ln>
+          <a:effectLst/>
+        </p:spPr>
+        <p:style>
+          <a:lnRef idx="1">
+            <a:schemeClr val="accent1"/>
+          </a:lnRef>
+          <a:fillRef idx="3">
+            <a:schemeClr val="accent1"/>
+          </a:fillRef>
+          <a:effectRef idx="2">
+            <a:schemeClr val="accent1"/>
+          </a:effectRef>
+          <a:fontRef idx="minor">
+            <a:schemeClr val="lt1"/>
+          </a:fontRef>
+        </p:style>
+        <p:txBody>
+          <a:bodyPr rtlCol="0" anchor="ctr"/>
+          <a:lstStyle/>
+          <a:p>
+            <a:pPr algn="ctr"/>
+          </a:p>
+        </p:txBody>
+      </p:sp>
+      <p:sp>
+        <p:nvSpPr>
+          <p:cNvPr id="16" name="TextBox 15"/>
+          <p:cNvSpPr txBox="1"/>
+          <p:nvPr/>
+        </p:nvSpPr>
+        <p:spPr>
+          <a:xfrm>
+            <a:off x="7269480" y="3813048"/>
+            <a:ext cx="2103120" cy="310896"/>
+          </a:xfrm>
+          <a:prstGeom prst="rect">
+            <a:avLst/>
+          </a:prstGeom>
+          <a:noFill/>
+        </p:spPr>
+        <p:txBody>
+          <a:bodyPr wrap="square" anchor="t" lIns="0" rIns="0" tIns="0" bIns="0">
+            <a:spAutoFit/>
+          </a:bodyPr>
+          <a:lstStyle/>
+          <a:p>
+            <a:pPr algn="l">
+              <a:spcAft>
+                <a:spcPts val="0"/>
+              </a:spcAft>
+            </a:pPr>
+            <a:r>
+              <a:rPr sz="1200" b="0">
+                <a:solidFill>
+                  <a:srgbClr val="1A1816"/>
+                </a:solidFill>
+                <a:latin typeface="Segoe UI"/>
+              </a:rPr>
+              <a:t>Card machine</a:t>
+            </a:r>
+          </a:p>
+        </p:txBody>
+      </p:sp>
+      <p:sp>
+        <p:nvSpPr>
+          <p:cNvPr id="17" name="TextBox 16"/>
+          <p:cNvSpPr txBox="1"/>
+          <p:nvPr/>
+        </p:nvSpPr>
+        <p:spPr>
+          <a:xfrm>
+            <a:off x="9372600" y="3813048"/>
+            <a:ext cx="1691640" cy="310896"/>
+          </a:xfrm>
+          <a:prstGeom prst="rect">
+            <a:avLst/>
+          </a:prstGeom>
+          <a:noFill/>
+        </p:spPr>
+        <p:txBody>
+          <a:bodyPr wrap="square" anchor="t" lIns="0" rIns="0" tIns="0" bIns="0">
+            <a:spAutoFit/>
+          </a:bodyPr>
+          <a:lstStyle/>
+          <a:p>
+            <a:pPr algn="r">
+              <a:spcAft>
+                <a:spcPts val="0"/>
+              </a:spcAft>
+            </a:pPr>
+            <a:r>
+              <a:rPr sz="1200" b="0">
+                <a:solidFill>
+                  <a:srgbClr val="7A7264"/>
+                </a:solidFill>
+                <a:latin typeface="Segoe UI"/>
+              </a:rPr>
+              <a:t>R0 — unchanged</a:t>
+            </a:r>
+          </a:p>
+        </p:txBody>
+      </p:sp>
+      <p:sp>
+        <p:nvSpPr>
+          <p:cNvPr id="18" name="Rectangle 17"/>
+          <p:cNvSpPr/>
+          <p:nvPr/>
+        </p:nvSpPr>
+        <p:spPr>
+          <a:xfrm>
+            <a:off x="7269480" y="4142232"/>
+            <a:ext cx="3794760" cy="9525"/>
+          </a:xfrm>
+          <a:prstGeom prst="rect">
+            <a:avLst/>
+          </a:prstGeom>
+          <a:solidFill>
+            <a:srgbClr val="EDEAE4"/>
+          </a:solidFill>
+          <a:ln>
+            <a:noFill/>
+          </a:ln>
+          <a:effectLst/>
+        </p:spPr>
+        <p:style>
+          <a:lnRef idx="1">
+            <a:schemeClr val="accent1"/>
+          </a:lnRef>
+          <a:fillRef idx="3">
+            <a:schemeClr val="accent1"/>
+          </a:fillRef>
+          <a:effectRef idx="2">
+            <a:schemeClr val="accent1"/>
+          </a:effectRef>
+          <a:fontRef idx="minor">
+            <a:schemeClr val="lt1"/>
+          </a:fontRef>
+        </p:style>
+        <p:txBody>
+          <a:bodyPr rtlCol="0" anchor="ctr"/>
+          <a:lstStyle/>
+          <a:p>
+            <a:pPr algn="ctr"/>
+          </a:p>
+        </p:txBody>
+      </p:sp>
+      <p:sp>
+        <p:nvSpPr>
+          <p:cNvPr id="19" name="TextBox 18"/>
+          <p:cNvSpPr txBox="1"/>
+          <p:nvPr/>
+        </p:nvSpPr>
+        <p:spPr>
+          <a:xfrm>
+            <a:off x="7269480" y="4233672"/>
+            <a:ext cx="2103120" cy="310896"/>
+          </a:xfrm>
+          <a:prstGeom prst="rect">
+            <a:avLst/>
+          </a:prstGeom>
+          <a:noFill/>
+        </p:spPr>
+        <p:txBody>
+          <a:bodyPr wrap="square" anchor="t" lIns="0" rIns="0" tIns="0" bIns="0">
+            <a:spAutoFit/>
+          </a:bodyPr>
+          <a:lstStyle/>
+          <a:p>
+            <a:pPr algn="l">
+              <a:spcAft>
+                <a:spcPts val="0"/>
+              </a:spcAft>
+            </a:pPr>
+            <a:r>
+              <a:rPr sz="1200" b="0">
+                <a:solidFill>
+                  <a:srgbClr val="1A1816"/>
+                </a:solidFill>
+                <a:latin typeface="Segoe UI"/>
+              </a:rPr>
+              <a:t>Messaging</a:t>
+            </a:r>
+          </a:p>
+        </p:txBody>
+      </p:sp>
+      <p:sp>
+        <p:nvSpPr>
+          <p:cNvPr id="20" name="TextBox 19"/>
+          <p:cNvSpPr txBox="1"/>
+          <p:nvPr/>
+        </p:nvSpPr>
+        <p:spPr>
+          <a:xfrm>
+            <a:off x="9372600" y="4233672"/>
+            <a:ext cx="1691640" cy="310896"/>
+          </a:xfrm>
+          <a:prstGeom prst="rect">
+            <a:avLst/>
+          </a:prstGeom>
+          <a:noFill/>
+        </p:spPr>
+        <p:txBody>
+          <a:bodyPr wrap="square" anchor="t" lIns="0" rIns="0" tIns="0" bIns="0">
+            <a:spAutoFit/>
+          </a:bodyPr>
+          <a:lstStyle/>
+          <a:p>
+            <a:pPr algn="r">
+              <a:spcAft>
+                <a:spcPts val="0"/>
+              </a:spcAft>
+            </a:pPr>
+            <a:r>
+              <a:rPr sz="1200" b="0">
+                <a:solidFill>
+                  <a:srgbClr val="7A7264"/>
+                </a:solidFill>
+                <a:latin typeface="Segoe UI"/>
+              </a:rPr>
+              <a:t>Pay-per-message</a:t>
+            </a:r>
+          </a:p>
+        </p:txBody>
+      </p:sp>
+      <p:sp>
+        <p:nvSpPr>
+          <p:cNvPr id="21" name="Rectangle 20"/>
+          <p:cNvSpPr/>
+          <p:nvPr/>
+        </p:nvSpPr>
+        <p:spPr>
+          <a:xfrm>
+            <a:off x="7269480" y="4562856"/>
+            <a:ext cx="3794760" cy="9525"/>
+          </a:xfrm>
+          <a:prstGeom prst="rect">
+            <a:avLst/>
+          </a:prstGeom>
+          <a:solidFill>
+            <a:srgbClr val="EDEAE4"/>
+          </a:solidFill>
+          <a:ln>
+            <a:noFill/>
+          </a:ln>
+          <a:effectLst/>
+        </p:spPr>
+        <p:style>
+          <a:lnRef idx="1">
+            <a:schemeClr val="accent1"/>
+          </a:lnRef>
+          <a:fillRef idx="3">
+            <a:schemeClr val="accent1"/>
+          </a:fillRef>
+          <a:effectRef idx="2">
+            <a:schemeClr val="accent1"/>
+          </a:effectRef>
+          <a:fontRef idx="minor">
+            <a:schemeClr val="lt1"/>
+          </a:fontRef>
+        </p:style>
+        <p:txBody>
+          <a:bodyPr rtlCol="0" anchor="ctr"/>
+          <a:lstStyle/>
+          <a:p>
+            <a:pPr algn="ctr"/>
+          </a:p>
+        </p:txBody>
+      </p:sp>
+      <p:sp>
+        <p:nvSpPr>
+          <p:cNvPr id="22" name="TextBox 21"/>
+          <p:cNvSpPr txBox="1"/>
+          <p:nvPr/>
+        </p:nvSpPr>
+        <p:spPr>
+          <a:xfrm>
+            <a:off x="7269480" y="4709160"/>
+            <a:ext cx="2103120" cy="365760"/>
+          </a:xfrm>
+          <a:prstGeom prst="rect">
+            <a:avLst/>
+          </a:prstGeom>
+          <a:noFill/>
+        </p:spPr>
+        <p:txBody>
+          <a:bodyPr wrap="square" anchor="t" lIns="0" rIns="0" tIns="0" bIns="0">
+            <a:spAutoFit/>
+          </a:bodyPr>
+          <a:lstStyle/>
+          <a:p>
+            <a:pPr algn="l">
+              <a:spcAft>
+                <a:spcPts val="0"/>
+              </a:spcAft>
+            </a:pPr>
+            <a:r>
+              <a:rPr sz="1300" b="1">
+                <a:solidFill>
+                  <a:srgbClr val="1A1816"/>
+                </a:solidFill>
+                <a:latin typeface="Segoe UI"/>
+              </a:rPr>
+              <a:t>Estimated to start</a:t>
+            </a:r>
+          </a:p>
+        </p:txBody>
+      </p:sp>
+      <p:sp>
+        <p:nvSpPr>
+          <p:cNvPr id="23" name="TextBox 22"/>
+          <p:cNvSpPr txBox="1"/>
+          <p:nvPr/>
+        </p:nvSpPr>
+        <p:spPr>
+          <a:xfrm>
+            <a:off x="9372600" y="4709160"/>
+            <a:ext cx="1691640" cy="365760"/>
+          </a:xfrm>
+          <a:prstGeom prst="rect">
+            <a:avLst/>
+          </a:prstGeom>
+          <a:noFill/>
+        </p:spPr>
+        <p:txBody>
+          <a:bodyPr wrap="square" anchor="t" lIns="0" rIns="0" tIns="0" bIns="0">
+            <a:spAutoFit/>
+          </a:bodyPr>
+          <a:lstStyle/>
+          <a:p>
+            <a:pPr algn="r">
+              <a:spcAft>
+                <a:spcPts val="0"/>
+              </a:spcAft>
+            </a:pPr>
+            <a:r>
+              <a:rPr sz="1300" b="1">
+                <a:solidFill>
+                  <a:srgbClr val="6E6455"/>
+                </a:solidFill>
+                <a:latin typeface="Segoe UI"/>
+              </a:rPr>
+              <a:t>≈ R380/mo</a:t>
+            </a:r>
+          </a:p>
+        </p:txBody>
+      </p:sp>
+      <p:sp>
+        <p:nvSpPr>
+          <p:cNvPr id="24" name="TextBox 23"/>
+          <p:cNvSpPr txBox="1"/>
+          <p:nvPr/>
+        </p:nvSpPr>
+        <p:spPr>
+          <a:xfrm>
+            <a:off x="822960" y="6172200"/>
+            <a:ext cx="10515600" cy="365760"/>
+          </a:xfrm>
+          <a:prstGeom prst="rect">
+            <a:avLst/>
+          </a:prstGeom>
+          <a:noFill/>
+        </p:spPr>
+        <p:txBody>
+          <a:bodyPr wrap="square" anchor="t" lIns="0" rIns="0" tIns="0" bIns="0">
+            <a:spAutoFit/>
+          </a:bodyPr>
+          <a:lstStyle/>
+          <a:p>
+            <a:pPr algn="l">
+              <a:spcAft>
+                <a:spcPts val="0"/>
+              </a:spcAft>
+            </a:pPr>
+            <a:r>
+              <a:rPr sz="1100" b="0">
+                <a:solidFill>
+                  <a:srgbClr val="7A7264"/>
+                </a:solidFill>
+                <a:latin typeface="Segoe UI"/>
+              </a:rPr>
+              <a:t>Figures current as of August 2026 — pricing and the Rand exchange rate will move over time.</a:t>
+            </a:r>
+          </a:p>
+        </p:txBody>
+      </p:sp>
+      <p:sp>
+        <p:nvSpPr>
+          <p:cNvPr id="25" name="TextBox 24"/>
+          <p:cNvSpPr txBox="1"/>
+          <p:nvPr/>
+        </p:nvSpPr>
+        <p:spPr>
+          <a:xfrm>
+            <a:off x="11002975" y="6291072"/>
+            <a:ext cx="640080" cy="274320"/>
+          </a:xfrm>
+          <a:prstGeom prst="rect">
+            <a:avLst/>
+          </a:prstGeom>
+          <a:noFill/>
+        </p:spPr>
+        <p:txBody>
+          <a:bodyPr wrap="square" anchor="t" lIns="0" rIns="0" tIns="0" bIns="0">
+            <a:spAutoFit/>
+          </a:bodyPr>
+          <a:lstStyle/>
+          <a:p>
+            <a:pPr algn="r">
+              <a:spcAft>
+                <a:spcPts val="0"/>
+              </a:spcAft>
+            </a:pPr>
+            <a:r>
+              <a:rPr sz="950" b="0">
+                <a:solidFill>
+                  <a:srgbClr val="7A7264"/>
+                </a:solidFill>
+                <a:latin typeface="Segoe UI"/>
+              </a:rPr>
+              <a:t>14</a:t>
+            </a:r>
+          </a:p>
+        </p:txBody>
+      </p:sp>
+    </p:spTree>
+  </p:cSld>
+  <p:clrMapOvr>
+    <a:masterClrMapping/>
+  </p:clrMapOvr>
+</p:sld>
+</file>
+
+<file path=ppt/slides/slide15.xml><?xml version="1.0" encoding="utf-8"?>
+<p:sld xmlns:a="http://schemas.openxmlformats.org/drawingml/2006/main" xmlns:p="http://schemas.openxmlformats.org/presentationml/2006/main" xmlns:r="http://schemas.openxmlformats.org/officeDocument/2006/relationships">
+  <p:cSld>
+    <p:spTree>
+      <p:nvGrpSpPr>
+        <p:cNvPr id="1" name=""/>
+        <p:cNvGrpSpPr/>
+        <p:nvPr/>
+      </p:nvGrpSpPr>
+      <p:grpSpPr/>
+      <p:sp>
+        <p:nvSpPr>
+          <p:cNvPr id="2" name="Rectangle 1"/>
+          <p:cNvSpPr/>
+          <p:nvPr/>
+        </p:nvSpPr>
+        <p:spPr>
+          <a:xfrm>
+            <a:off x="0" y="0"/>
+            <a:ext cx="12191695" cy="6858000"/>
+          </a:xfrm>
+          <a:prstGeom prst="rect">
+            <a:avLst/>
+          </a:prstGeom>
+          <a:solidFill>
+            <a:srgbClr val="FAF9F7"/>
+          </a:solidFill>
+          <a:ln>
+            <a:noFill/>
+          </a:ln>
+          <a:effectLst/>
+        </p:spPr>
+        <p:style>
+          <a:lnRef idx="1">
+            <a:schemeClr val="accent1"/>
+          </a:lnRef>
+          <a:fillRef idx="3">
+            <a:schemeClr val="accent1"/>
+          </a:fillRef>
+          <a:effectRef idx="2">
+            <a:schemeClr val="accent1"/>
+          </a:effectRef>
+          <a:fontRef idx="minor">
+            <a:schemeClr val="lt1"/>
+          </a:fontRef>
+        </p:style>
+        <p:txBody>
+          <a:bodyPr rtlCol="0" anchor="ctr"/>
+          <a:lstStyle/>
+          <a:p>
+            <a:pPr algn="ctr"/>
+          </a:p>
+        </p:txBody>
+      </p:sp>
+      <p:sp>
+        <p:nvSpPr>
+          <p:cNvPr id="3" name="TextBox 2"/>
+          <p:cNvSpPr txBox="1"/>
+          <p:nvPr/>
+        </p:nvSpPr>
+        <p:spPr>
+          <a:xfrm>
+            <a:off x="822960" y="457200"/>
+            <a:ext cx="2743200" cy="548640"/>
+          </a:xfrm>
+          <a:prstGeom prst="rect">
+            <a:avLst/>
+          </a:prstGeom>
+          <a:noFill/>
+        </p:spPr>
+        <p:txBody>
+          <a:bodyPr wrap="square" anchor="t" lIns="0" rIns="0" tIns="0" bIns="0">
+            <a:spAutoFit/>
+          </a:bodyPr>
+          <a:lstStyle/>
+          <a:p>
+            <a:r>
+              <a:rPr sz="1500">
+                <a:solidFill>
+                  <a:srgbClr val="8A7F6F"/>
+                </a:solidFill>
+                <a:latin typeface="Segoe UI Light"/>
+              </a:rPr>
+              <a:t>HAIR</a:t>
+            </a:r>
+            <a:r>
+              <a:rPr sz="1500">
+                <a:solidFill>
+                  <a:srgbClr val="1A1816"/>
+                </a:solidFill>
+                <a:latin typeface="Segoe UI Light"/>
+              </a:rPr>
+              <a:t>|</a:t>
+            </a:r>
+            <a:r>
+              <a:rPr sz="1500">
+                <a:solidFill>
+                  <a:srgbClr val="1A1816"/>
+                </a:solidFill>
+                <a:latin typeface="Segoe UI Light"/>
+              </a:rPr>
+              <a:t>line</a:t>
+            </a:r>
+          </a:p>
+        </p:txBody>
+      </p:sp>
+      <p:sp>
+        <p:nvSpPr>
+          <p:cNvPr id="4" name="TextBox 3"/>
+          <p:cNvSpPr txBox="1"/>
+          <p:nvPr/>
+        </p:nvSpPr>
+        <p:spPr>
+          <a:xfrm>
+            <a:off x="822960" y="1051560"/>
+            <a:ext cx="8229600" cy="274320"/>
+          </a:xfrm>
+          <a:prstGeom prst="rect">
+            <a:avLst/>
+          </a:prstGeom>
+          <a:noFill/>
+        </p:spPr>
+        <p:txBody>
+          <a:bodyPr wrap="square" anchor="t" lIns="0" rIns="0" tIns="0" bIns="0">
+            <a:spAutoFit/>
+          </a:bodyPr>
+          <a:lstStyle/>
+          <a:p>
+            <a:pPr algn="l">
+              <a:spcAft>
+                <a:spcPts val="0"/>
+              </a:spcAft>
+            </a:pPr>
+            <a:r>
+              <a:rPr sz="1050" b="1" spc="180">
+                <a:solidFill>
+                  <a:srgbClr val="8A7F6F"/>
+                </a:solidFill>
+                <a:latin typeface="Segoe UI"/>
+              </a:rPr>
               <a:t>OVER TO YOU</a:t>
             </a:r>
           </a:p>
@@ -7737,7 +8879,7 @@
                 </a:solidFill>
                 <a:latin typeface="Segoe UI"/>
               </a:rPr>
-              <a:t>14</a:t>
+              <a:t>15</a:t>
             </a:r>
           </a:p>
         </p:txBody>

</xml_diff>

<commit_message>
docs: refresh deck, PowerPoint and user guide for the reception feedback build
</commit_message>
<xml_diff>
--- a/docs/Hairline Salon Manager - Presentation.pptx
+++ b/docs/Hairline Salon Manager - Presentation.pptx
@@ -19,7 +19,6 @@
     <p:sldId id="267" r:id="rId18"/>
     <p:sldId id="268" r:id="rId19"/>
     <p:sldId id="269" r:id="rId20"/>
-    <p:sldId id="270" r:id="rId21"/>
   </p:sldIdLst>
   <p:sldSz cx="12191695" cy="6858000" type="screen4x3"/>
   <p:notesSz cx="6858000" cy="9144000"/>
@@ -6698,1147 +6697,6 @@
                 </a:solidFill>
                 <a:latin typeface="Segoe UI"/>
               </a:rPr>
-              <a:t>WHAT IT COSTS TO RUN</a:t>
-            </a:r>
-          </a:p>
-        </p:txBody>
-      </p:sp>
-      <p:sp>
-        <p:nvSpPr>
-          <p:cNvPr id="5" name="TextBox 4"/>
-          <p:cNvSpPr txBox="1"/>
-          <p:nvPr/>
-        </p:nvSpPr>
-        <p:spPr>
-          <a:xfrm>
-            <a:off x="822960" y="1371600"/>
-            <a:ext cx="9601200" cy="1188720"/>
-          </a:xfrm>
-          <a:prstGeom prst="rect">
-            <a:avLst/>
-          </a:prstGeom>
-          <a:noFill/>
-        </p:spPr>
-        <p:txBody>
-          <a:bodyPr wrap="square" anchor="t" lIns="0" rIns="0" tIns="0" bIns="0">
-            <a:spAutoFit/>
-          </a:bodyPr>
-          <a:lstStyle/>
-          <a:p>
-            <a:pPr algn="l">
-              <a:lnSpc>
-                <a:spcPct val="105000"/>
-              </a:lnSpc>
-              <a:spcAft>
-                <a:spcPts val="0"/>
-              </a:spcAft>
-            </a:pPr>
-            <a:r>
-              <a:rPr sz="3000" b="0">
-                <a:solidFill>
-                  <a:srgbClr val="1A1816"/>
-                </a:solidFill>
-                <a:latin typeface="Segoe UI Light"/>
-              </a:rPr>
-              <a:t>Hosting and the database, at a glance.</a:t>
-            </a:r>
-          </a:p>
-        </p:txBody>
-      </p:sp>
-      <p:sp>
-        <p:nvSpPr>
-          <p:cNvPr id="6" name="TextBox 5"/>
-          <p:cNvSpPr txBox="1"/>
-          <p:nvPr/>
-        </p:nvSpPr>
-        <p:spPr>
-          <a:xfrm>
-            <a:off x="822960" y="2514600"/>
-            <a:ext cx="5760720" cy="3291840"/>
-          </a:xfrm>
-          <a:prstGeom prst="rect">
-            <a:avLst/>
-          </a:prstGeom>
-          <a:noFill/>
-        </p:spPr>
-        <p:txBody>
-          <a:bodyPr wrap="square" anchor="t" lIns="0" rIns="0" tIns="0" bIns="0">
-            <a:spAutoFit/>
-          </a:bodyPr>
-          <a:lstStyle/>
-          <a:p>
-            <a:pPr>
-              <a:lnSpc>
-                <a:spcPct val="128000"/>
-              </a:lnSpc>
-              <a:spcAft>
-                <a:spcPts val="1200"/>
-              </a:spcAft>
-            </a:pPr>
-            <a:r>
-              <a:rPr sz="1350">
-                <a:solidFill>
-                  <a:srgbClr val="8A7F6F"/>
-                </a:solidFill>
-                <a:latin typeface="Segoe UI"/>
-              </a:rPr>
-              <a:t>—   </a:t>
-            </a:r>
-            <a:r>
-              <a:rPr sz="1350" b="1">
-                <a:solidFill>
-                  <a:srgbClr val="1A1816"/>
-                </a:solidFill>
-                <a:latin typeface="Segoe UI"/>
-              </a:rPr>
-              <a:t>Hosting (Vercel).</a:t>
-            </a:r>
-            <a:r>
-              <a:rPr sz="1350">
-                <a:solidFill>
-                  <a:srgbClr val="3A362F"/>
-                </a:solidFill>
-                <a:latin typeface="Segoe UI"/>
-              </a:rPr>
-              <a:t> Pro plan, $20 per user a month (≈R380) — the free tier is personal-use only, and a trading salon needs Pro.</a:t>
-            </a:r>
-          </a:p>
-          <a:p>
-            <a:pPr>
-              <a:lnSpc>
-                <a:spcPct val="128000"/>
-              </a:lnSpc>
-              <a:spcAft>
-                <a:spcPts val="1200"/>
-              </a:spcAft>
-            </a:pPr>
-            <a:r>
-              <a:rPr sz="1350">
-                <a:solidFill>
-                  <a:srgbClr val="8A7F6F"/>
-                </a:solidFill>
-                <a:latin typeface="Segoe UI"/>
-              </a:rPr>
-              <a:t>—   </a:t>
-            </a:r>
-            <a:r>
-              <a:rPr sz="1350" b="1">
-                <a:solidFill>
-                  <a:srgbClr val="1A1816"/>
-                </a:solidFill>
-                <a:latin typeface="Segoe UI"/>
-              </a:rPr>
-              <a:t>Database (Neon Postgres).</a:t>
-            </a:r>
-            <a:r>
-              <a:rPr sz="1350">
-                <a:solidFill>
-                  <a:srgbClr val="3A362F"/>
-                </a:solidFill>
-                <a:latin typeface="Segoe UI"/>
-              </a:rPr>
-              <a:t> Free tier — 0.5GB storage, 100 compute-hours a month — comfortably covers Hairline's data; usage-based only if outgrown.</a:t>
-            </a:r>
-          </a:p>
-          <a:p>
-            <a:pPr>
-              <a:lnSpc>
-                <a:spcPct val="128000"/>
-              </a:lnSpc>
-              <a:spcAft>
-                <a:spcPts val="1200"/>
-              </a:spcAft>
-            </a:pPr>
-            <a:r>
-              <a:rPr sz="1350">
-                <a:solidFill>
-                  <a:srgbClr val="8A7F6F"/>
-                </a:solidFill>
-                <a:latin typeface="Segoe UI"/>
-              </a:rPr>
-              <a:t>—   </a:t>
-            </a:r>
-            <a:r>
-              <a:rPr sz="1350" b="1">
-                <a:solidFill>
-                  <a:srgbClr val="1A1816"/>
-                </a:solidFill>
-                <a:latin typeface="Segoe UI"/>
-              </a:rPr>
-              <a:t>Card machine.</a:t>
-            </a:r>
-            <a:r>
-              <a:rPr sz="1350">
-                <a:solidFill>
-                  <a:srgbClr val="3A362F"/>
-                </a:solidFill>
-                <a:latin typeface="Segoe UI"/>
-              </a:rPr>
-              <a:t> No change and no new cost — the standalone terminal stays exactly as it is today.</a:t>
-            </a:r>
-          </a:p>
-          <a:p>
-            <a:pPr>
-              <a:lnSpc>
-                <a:spcPct val="128000"/>
-              </a:lnSpc>
-              <a:spcAft>
-                <a:spcPts val="1200"/>
-              </a:spcAft>
-            </a:pPr>
-            <a:r>
-              <a:rPr sz="1350">
-                <a:solidFill>
-                  <a:srgbClr val="8A7F6F"/>
-                </a:solidFill>
-                <a:latin typeface="Segoe UI"/>
-              </a:rPr>
-              <a:t>—   </a:t>
-            </a:r>
-            <a:r>
-              <a:rPr sz="1350" b="1">
-                <a:solidFill>
-                  <a:srgbClr val="1A1816"/>
-                </a:solidFill>
-                <a:latin typeface="Segoe UI"/>
-              </a:rPr>
-              <a:t>Messaging (SMS/WhatsApp).</a:t>
-            </a:r>
-            <a:r>
-              <a:rPr sz="1350">
-                <a:solidFill>
-                  <a:srgbClr val="3A362F"/>
-                </a:solidFill>
-                <a:latin typeface="Segoe UI"/>
-              </a:rPr>
-              <a:t> Billed per message sent, separately from hosting.</a:t>
-            </a:r>
-          </a:p>
-        </p:txBody>
-      </p:sp>
-      <p:sp>
-        <p:nvSpPr>
-          <p:cNvPr id="7" name="Rounded Rectangle 6"/>
-          <p:cNvSpPr/>
-          <p:nvPr/>
-        </p:nvSpPr>
-        <p:spPr>
-          <a:xfrm>
-            <a:off x="6949440" y="2331720"/>
-            <a:ext cx="4434840" cy="3063240"/>
-          </a:xfrm>
-          <a:prstGeom prst="roundRect">
-            <a:avLst>
-              <a:gd name="adj" fmla="val 3000"/>
-            </a:avLst>
-          </a:prstGeom>
-          <a:solidFill>
-            <a:srgbClr val="FFFFFF"/>
-          </a:solidFill>
-          <a:ln w="9525">
-            <a:solidFill>
-              <a:srgbClr val="E2DED7"/>
-            </a:solidFill>
-          </a:ln>
-          <a:effectLst/>
-        </p:spPr>
-        <p:style>
-          <a:lnRef idx="1">
-            <a:schemeClr val="accent1"/>
-          </a:lnRef>
-          <a:fillRef idx="3">
-            <a:schemeClr val="accent1"/>
-          </a:fillRef>
-          <a:effectRef idx="2">
-            <a:schemeClr val="accent1"/>
-          </a:effectRef>
-          <a:fontRef idx="minor">
-            <a:schemeClr val="lt1"/>
-          </a:fontRef>
-        </p:style>
-        <p:txBody>
-          <a:bodyPr rtlCol="0" anchor="ctr"/>
-          <a:lstStyle/>
-          <a:p>
-            <a:pPr algn="ctr"/>
-          </a:p>
-        </p:txBody>
-      </p:sp>
-      <p:sp>
-        <p:nvSpPr>
-          <p:cNvPr id="8" name="TextBox 7"/>
-          <p:cNvSpPr txBox="1"/>
-          <p:nvPr/>
-        </p:nvSpPr>
-        <p:spPr>
-          <a:xfrm>
-            <a:off x="7269480" y="2560320"/>
-            <a:ext cx="3794760" cy="274320"/>
-          </a:xfrm>
-          <a:prstGeom prst="rect">
-            <a:avLst/>
-          </a:prstGeom>
-          <a:noFill/>
-        </p:spPr>
-        <p:txBody>
-          <a:bodyPr wrap="square" anchor="t" lIns="0" rIns="0" tIns="0" bIns="0">
-            <a:spAutoFit/>
-          </a:bodyPr>
-          <a:lstStyle/>
-          <a:p>
-            <a:pPr algn="l">
-              <a:spcAft>
-                <a:spcPts val="0"/>
-              </a:spcAft>
-            </a:pPr>
-            <a:r>
-              <a:rPr sz="950" b="1" spc="120">
-                <a:solidFill>
-                  <a:srgbClr val="8A7F6F"/>
-                </a:solidFill>
-                <a:latin typeface="Segoe UI"/>
-              </a:rPr>
-              <a:t>TYPICAL MONTHLY COST</a:t>
-            </a:r>
-          </a:p>
-        </p:txBody>
-      </p:sp>
-      <p:sp>
-        <p:nvSpPr>
-          <p:cNvPr id="9" name="Rectangle 8"/>
-          <p:cNvSpPr/>
-          <p:nvPr/>
-        </p:nvSpPr>
-        <p:spPr>
-          <a:xfrm>
-            <a:off x="7269480" y="2834640"/>
-            <a:ext cx="3794760" cy="9525"/>
-          </a:xfrm>
-          <a:prstGeom prst="rect">
-            <a:avLst/>
-          </a:prstGeom>
-          <a:solidFill>
-            <a:srgbClr val="8A7F6F"/>
-          </a:solidFill>
-          <a:ln>
-            <a:noFill/>
-          </a:ln>
-          <a:effectLst/>
-        </p:spPr>
-        <p:style>
-          <a:lnRef idx="1">
-            <a:schemeClr val="accent1"/>
-          </a:lnRef>
-          <a:fillRef idx="3">
-            <a:schemeClr val="accent1"/>
-          </a:fillRef>
-          <a:effectRef idx="2">
-            <a:schemeClr val="accent1"/>
-          </a:effectRef>
-          <a:fontRef idx="minor">
-            <a:schemeClr val="lt1"/>
-          </a:fontRef>
-        </p:style>
-        <p:txBody>
-          <a:bodyPr rtlCol="0" anchor="ctr"/>
-          <a:lstStyle/>
-          <a:p>
-            <a:pPr algn="ctr"/>
-          </a:p>
-        </p:txBody>
-      </p:sp>
-      <p:sp>
-        <p:nvSpPr>
-          <p:cNvPr id="10" name="TextBox 9"/>
-          <p:cNvSpPr txBox="1"/>
-          <p:nvPr/>
-        </p:nvSpPr>
-        <p:spPr>
-          <a:xfrm>
-            <a:off x="7269480" y="2971800"/>
-            <a:ext cx="2103120" cy="310896"/>
-          </a:xfrm>
-          <a:prstGeom prst="rect">
-            <a:avLst/>
-          </a:prstGeom>
-          <a:noFill/>
-        </p:spPr>
-        <p:txBody>
-          <a:bodyPr wrap="square" anchor="t" lIns="0" rIns="0" tIns="0" bIns="0">
-            <a:spAutoFit/>
-          </a:bodyPr>
-          <a:lstStyle/>
-          <a:p>
-            <a:pPr algn="l">
-              <a:spcAft>
-                <a:spcPts val="0"/>
-              </a:spcAft>
-            </a:pPr>
-            <a:r>
-              <a:rPr sz="1200" b="0">
-                <a:solidFill>
-                  <a:srgbClr val="1A1816"/>
-                </a:solidFill>
-                <a:latin typeface="Segoe UI"/>
-              </a:rPr>
-              <a:t>Hosting — Vercel Pro</a:t>
-            </a:r>
-          </a:p>
-        </p:txBody>
-      </p:sp>
-      <p:sp>
-        <p:nvSpPr>
-          <p:cNvPr id="11" name="TextBox 10"/>
-          <p:cNvSpPr txBox="1"/>
-          <p:nvPr/>
-        </p:nvSpPr>
-        <p:spPr>
-          <a:xfrm>
-            <a:off x="9372600" y="2971800"/>
-            <a:ext cx="1691640" cy="310896"/>
-          </a:xfrm>
-          <a:prstGeom prst="rect">
-            <a:avLst/>
-          </a:prstGeom>
-          <a:noFill/>
-        </p:spPr>
-        <p:txBody>
-          <a:bodyPr wrap="square" anchor="t" lIns="0" rIns="0" tIns="0" bIns="0">
-            <a:spAutoFit/>
-          </a:bodyPr>
-          <a:lstStyle/>
-          <a:p>
-            <a:pPr algn="r">
-              <a:spcAft>
-                <a:spcPts val="0"/>
-              </a:spcAft>
-            </a:pPr>
-            <a:r>
-              <a:rPr sz="1200" b="0">
-                <a:solidFill>
-                  <a:srgbClr val="7A7264"/>
-                </a:solidFill>
-                <a:latin typeface="Segoe UI"/>
-              </a:rPr>
-              <a:t>≈ R380</a:t>
-            </a:r>
-          </a:p>
-        </p:txBody>
-      </p:sp>
-      <p:sp>
-        <p:nvSpPr>
-          <p:cNvPr id="12" name="Rectangle 11"/>
-          <p:cNvSpPr/>
-          <p:nvPr/>
-        </p:nvSpPr>
-        <p:spPr>
-          <a:xfrm>
-            <a:off x="7269480" y="3300984"/>
-            <a:ext cx="3794760" cy="9525"/>
-          </a:xfrm>
-          <a:prstGeom prst="rect">
-            <a:avLst/>
-          </a:prstGeom>
-          <a:solidFill>
-            <a:srgbClr val="EDEAE4"/>
-          </a:solidFill>
-          <a:ln>
-            <a:noFill/>
-          </a:ln>
-          <a:effectLst/>
-        </p:spPr>
-        <p:style>
-          <a:lnRef idx="1">
-            <a:schemeClr val="accent1"/>
-          </a:lnRef>
-          <a:fillRef idx="3">
-            <a:schemeClr val="accent1"/>
-          </a:fillRef>
-          <a:effectRef idx="2">
-            <a:schemeClr val="accent1"/>
-          </a:effectRef>
-          <a:fontRef idx="minor">
-            <a:schemeClr val="lt1"/>
-          </a:fontRef>
-        </p:style>
-        <p:txBody>
-          <a:bodyPr rtlCol="0" anchor="ctr"/>
-          <a:lstStyle/>
-          <a:p>
-            <a:pPr algn="ctr"/>
-          </a:p>
-        </p:txBody>
-      </p:sp>
-      <p:sp>
-        <p:nvSpPr>
-          <p:cNvPr id="13" name="TextBox 12"/>
-          <p:cNvSpPr txBox="1"/>
-          <p:nvPr/>
-        </p:nvSpPr>
-        <p:spPr>
-          <a:xfrm>
-            <a:off x="7269480" y="3392424"/>
-            <a:ext cx="2103120" cy="310896"/>
-          </a:xfrm>
-          <a:prstGeom prst="rect">
-            <a:avLst/>
-          </a:prstGeom>
-          <a:noFill/>
-        </p:spPr>
-        <p:txBody>
-          <a:bodyPr wrap="square" anchor="t" lIns="0" rIns="0" tIns="0" bIns="0">
-            <a:spAutoFit/>
-          </a:bodyPr>
-          <a:lstStyle/>
-          <a:p>
-            <a:pPr algn="l">
-              <a:spcAft>
-                <a:spcPts val="0"/>
-              </a:spcAft>
-            </a:pPr>
-            <a:r>
-              <a:rPr sz="1200" b="0">
-                <a:solidFill>
-                  <a:srgbClr val="1A1816"/>
-                </a:solidFill>
-                <a:latin typeface="Segoe UI"/>
-              </a:rPr>
-              <a:t>Database — Neon</a:t>
-            </a:r>
-          </a:p>
-        </p:txBody>
-      </p:sp>
-      <p:sp>
-        <p:nvSpPr>
-          <p:cNvPr id="14" name="TextBox 13"/>
-          <p:cNvSpPr txBox="1"/>
-          <p:nvPr/>
-        </p:nvSpPr>
-        <p:spPr>
-          <a:xfrm>
-            <a:off x="9372600" y="3392424"/>
-            <a:ext cx="1691640" cy="310896"/>
-          </a:xfrm>
-          <a:prstGeom prst="rect">
-            <a:avLst/>
-          </a:prstGeom>
-          <a:noFill/>
-        </p:spPr>
-        <p:txBody>
-          <a:bodyPr wrap="square" anchor="t" lIns="0" rIns="0" tIns="0" bIns="0">
-            <a:spAutoFit/>
-          </a:bodyPr>
-          <a:lstStyle/>
-          <a:p>
-            <a:pPr algn="r">
-              <a:spcAft>
-                <a:spcPts val="0"/>
-              </a:spcAft>
-            </a:pPr>
-            <a:r>
-              <a:rPr sz="1200" b="0">
-                <a:solidFill>
-                  <a:srgbClr val="7A7264"/>
-                </a:solidFill>
-                <a:latin typeface="Segoe UI"/>
-              </a:rPr>
-              <a:t>R0 in free tier</a:t>
-            </a:r>
-          </a:p>
-        </p:txBody>
-      </p:sp>
-      <p:sp>
-        <p:nvSpPr>
-          <p:cNvPr id="15" name="Rectangle 14"/>
-          <p:cNvSpPr/>
-          <p:nvPr/>
-        </p:nvSpPr>
-        <p:spPr>
-          <a:xfrm>
-            <a:off x="7269480" y="3721608"/>
-            <a:ext cx="3794760" cy="9525"/>
-          </a:xfrm>
-          <a:prstGeom prst="rect">
-            <a:avLst/>
-          </a:prstGeom>
-          <a:solidFill>
-            <a:srgbClr val="EDEAE4"/>
-          </a:solidFill>
-          <a:ln>
-            <a:noFill/>
-          </a:ln>
-          <a:effectLst/>
-        </p:spPr>
-        <p:style>
-          <a:lnRef idx="1">
-            <a:schemeClr val="accent1"/>
-          </a:lnRef>
-          <a:fillRef idx="3">
-            <a:schemeClr val="accent1"/>
-          </a:fillRef>
-          <a:effectRef idx="2">
-            <a:schemeClr val="accent1"/>
-          </a:effectRef>
-          <a:fontRef idx="minor">
-            <a:schemeClr val="lt1"/>
-          </a:fontRef>
-        </p:style>
-        <p:txBody>
-          <a:bodyPr rtlCol="0" anchor="ctr"/>
-          <a:lstStyle/>
-          <a:p>
-            <a:pPr algn="ctr"/>
-          </a:p>
-        </p:txBody>
-      </p:sp>
-      <p:sp>
-        <p:nvSpPr>
-          <p:cNvPr id="16" name="TextBox 15"/>
-          <p:cNvSpPr txBox="1"/>
-          <p:nvPr/>
-        </p:nvSpPr>
-        <p:spPr>
-          <a:xfrm>
-            <a:off x="7269480" y="3813048"/>
-            <a:ext cx="2103120" cy="310896"/>
-          </a:xfrm>
-          <a:prstGeom prst="rect">
-            <a:avLst/>
-          </a:prstGeom>
-          <a:noFill/>
-        </p:spPr>
-        <p:txBody>
-          <a:bodyPr wrap="square" anchor="t" lIns="0" rIns="0" tIns="0" bIns="0">
-            <a:spAutoFit/>
-          </a:bodyPr>
-          <a:lstStyle/>
-          <a:p>
-            <a:pPr algn="l">
-              <a:spcAft>
-                <a:spcPts val="0"/>
-              </a:spcAft>
-            </a:pPr>
-            <a:r>
-              <a:rPr sz="1200" b="0">
-                <a:solidFill>
-                  <a:srgbClr val="1A1816"/>
-                </a:solidFill>
-                <a:latin typeface="Segoe UI"/>
-              </a:rPr>
-              <a:t>Card machine</a:t>
-            </a:r>
-          </a:p>
-        </p:txBody>
-      </p:sp>
-      <p:sp>
-        <p:nvSpPr>
-          <p:cNvPr id="17" name="TextBox 16"/>
-          <p:cNvSpPr txBox="1"/>
-          <p:nvPr/>
-        </p:nvSpPr>
-        <p:spPr>
-          <a:xfrm>
-            <a:off x="9372600" y="3813048"/>
-            <a:ext cx="1691640" cy="310896"/>
-          </a:xfrm>
-          <a:prstGeom prst="rect">
-            <a:avLst/>
-          </a:prstGeom>
-          <a:noFill/>
-        </p:spPr>
-        <p:txBody>
-          <a:bodyPr wrap="square" anchor="t" lIns="0" rIns="0" tIns="0" bIns="0">
-            <a:spAutoFit/>
-          </a:bodyPr>
-          <a:lstStyle/>
-          <a:p>
-            <a:pPr algn="r">
-              <a:spcAft>
-                <a:spcPts val="0"/>
-              </a:spcAft>
-            </a:pPr>
-            <a:r>
-              <a:rPr sz="1200" b="0">
-                <a:solidFill>
-                  <a:srgbClr val="7A7264"/>
-                </a:solidFill>
-                <a:latin typeface="Segoe UI"/>
-              </a:rPr>
-              <a:t>R0 — unchanged</a:t>
-            </a:r>
-          </a:p>
-        </p:txBody>
-      </p:sp>
-      <p:sp>
-        <p:nvSpPr>
-          <p:cNvPr id="18" name="Rectangle 17"/>
-          <p:cNvSpPr/>
-          <p:nvPr/>
-        </p:nvSpPr>
-        <p:spPr>
-          <a:xfrm>
-            <a:off x="7269480" y="4142232"/>
-            <a:ext cx="3794760" cy="9525"/>
-          </a:xfrm>
-          <a:prstGeom prst="rect">
-            <a:avLst/>
-          </a:prstGeom>
-          <a:solidFill>
-            <a:srgbClr val="EDEAE4"/>
-          </a:solidFill>
-          <a:ln>
-            <a:noFill/>
-          </a:ln>
-          <a:effectLst/>
-        </p:spPr>
-        <p:style>
-          <a:lnRef idx="1">
-            <a:schemeClr val="accent1"/>
-          </a:lnRef>
-          <a:fillRef idx="3">
-            <a:schemeClr val="accent1"/>
-          </a:fillRef>
-          <a:effectRef idx="2">
-            <a:schemeClr val="accent1"/>
-          </a:effectRef>
-          <a:fontRef idx="minor">
-            <a:schemeClr val="lt1"/>
-          </a:fontRef>
-        </p:style>
-        <p:txBody>
-          <a:bodyPr rtlCol="0" anchor="ctr"/>
-          <a:lstStyle/>
-          <a:p>
-            <a:pPr algn="ctr"/>
-          </a:p>
-        </p:txBody>
-      </p:sp>
-      <p:sp>
-        <p:nvSpPr>
-          <p:cNvPr id="19" name="TextBox 18"/>
-          <p:cNvSpPr txBox="1"/>
-          <p:nvPr/>
-        </p:nvSpPr>
-        <p:spPr>
-          <a:xfrm>
-            <a:off x="7269480" y="4233672"/>
-            <a:ext cx="2103120" cy="310896"/>
-          </a:xfrm>
-          <a:prstGeom prst="rect">
-            <a:avLst/>
-          </a:prstGeom>
-          <a:noFill/>
-        </p:spPr>
-        <p:txBody>
-          <a:bodyPr wrap="square" anchor="t" lIns="0" rIns="0" tIns="0" bIns="0">
-            <a:spAutoFit/>
-          </a:bodyPr>
-          <a:lstStyle/>
-          <a:p>
-            <a:pPr algn="l">
-              <a:spcAft>
-                <a:spcPts val="0"/>
-              </a:spcAft>
-            </a:pPr>
-            <a:r>
-              <a:rPr sz="1200" b="0">
-                <a:solidFill>
-                  <a:srgbClr val="1A1816"/>
-                </a:solidFill>
-                <a:latin typeface="Segoe UI"/>
-              </a:rPr>
-              <a:t>Messaging</a:t>
-            </a:r>
-          </a:p>
-        </p:txBody>
-      </p:sp>
-      <p:sp>
-        <p:nvSpPr>
-          <p:cNvPr id="20" name="TextBox 19"/>
-          <p:cNvSpPr txBox="1"/>
-          <p:nvPr/>
-        </p:nvSpPr>
-        <p:spPr>
-          <a:xfrm>
-            <a:off x="9372600" y="4233672"/>
-            <a:ext cx="1691640" cy="310896"/>
-          </a:xfrm>
-          <a:prstGeom prst="rect">
-            <a:avLst/>
-          </a:prstGeom>
-          <a:noFill/>
-        </p:spPr>
-        <p:txBody>
-          <a:bodyPr wrap="square" anchor="t" lIns="0" rIns="0" tIns="0" bIns="0">
-            <a:spAutoFit/>
-          </a:bodyPr>
-          <a:lstStyle/>
-          <a:p>
-            <a:pPr algn="r">
-              <a:spcAft>
-                <a:spcPts val="0"/>
-              </a:spcAft>
-            </a:pPr>
-            <a:r>
-              <a:rPr sz="1200" b="0">
-                <a:solidFill>
-                  <a:srgbClr val="7A7264"/>
-                </a:solidFill>
-                <a:latin typeface="Segoe UI"/>
-              </a:rPr>
-              <a:t>Pay-per-message</a:t>
-            </a:r>
-          </a:p>
-        </p:txBody>
-      </p:sp>
-      <p:sp>
-        <p:nvSpPr>
-          <p:cNvPr id="21" name="Rectangle 20"/>
-          <p:cNvSpPr/>
-          <p:nvPr/>
-        </p:nvSpPr>
-        <p:spPr>
-          <a:xfrm>
-            <a:off x="7269480" y="4562856"/>
-            <a:ext cx="3794760" cy="9525"/>
-          </a:xfrm>
-          <a:prstGeom prst="rect">
-            <a:avLst/>
-          </a:prstGeom>
-          <a:solidFill>
-            <a:srgbClr val="EDEAE4"/>
-          </a:solidFill>
-          <a:ln>
-            <a:noFill/>
-          </a:ln>
-          <a:effectLst/>
-        </p:spPr>
-        <p:style>
-          <a:lnRef idx="1">
-            <a:schemeClr val="accent1"/>
-          </a:lnRef>
-          <a:fillRef idx="3">
-            <a:schemeClr val="accent1"/>
-          </a:fillRef>
-          <a:effectRef idx="2">
-            <a:schemeClr val="accent1"/>
-          </a:effectRef>
-          <a:fontRef idx="minor">
-            <a:schemeClr val="lt1"/>
-          </a:fontRef>
-        </p:style>
-        <p:txBody>
-          <a:bodyPr rtlCol="0" anchor="ctr"/>
-          <a:lstStyle/>
-          <a:p>
-            <a:pPr algn="ctr"/>
-          </a:p>
-        </p:txBody>
-      </p:sp>
-      <p:sp>
-        <p:nvSpPr>
-          <p:cNvPr id="22" name="TextBox 21"/>
-          <p:cNvSpPr txBox="1"/>
-          <p:nvPr/>
-        </p:nvSpPr>
-        <p:spPr>
-          <a:xfrm>
-            <a:off x="7269480" y="4709160"/>
-            <a:ext cx="2103120" cy="365760"/>
-          </a:xfrm>
-          <a:prstGeom prst="rect">
-            <a:avLst/>
-          </a:prstGeom>
-          <a:noFill/>
-        </p:spPr>
-        <p:txBody>
-          <a:bodyPr wrap="square" anchor="t" lIns="0" rIns="0" tIns="0" bIns="0">
-            <a:spAutoFit/>
-          </a:bodyPr>
-          <a:lstStyle/>
-          <a:p>
-            <a:pPr algn="l">
-              <a:spcAft>
-                <a:spcPts val="0"/>
-              </a:spcAft>
-            </a:pPr>
-            <a:r>
-              <a:rPr sz="1300" b="1">
-                <a:solidFill>
-                  <a:srgbClr val="1A1816"/>
-                </a:solidFill>
-                <a:latin typeface="Segoe UI"/>
-              </a:rPr>
-              <a:t>Estimated to start</a:t>
-            </a:r>
-          </a:p>
-        </p:txBody>
-      </p:sp>
-      <p:sp>
-        <p:nvSpPr>
-          <p:cNvPr id="23" name="TextBox 22"/>
-          <p:cNvSpPr txBox="1"/>
-          <p:nvPr/>
-        </p:nvSpPr>
-        <p:spPr>
-          <a:xfrm>
-            <a:off x="9372600" y="4709160"/>
-            <a:ext cx="1691640" cy="365760"/>
-          </a:xfrm>
-          <a:prstGeom prst="rect">
-            <a:avLst/>
-          </a:prstGeom>
-          <a:noFill/>
-        </p:spPr>
-        <p:txBody>
-          <a:bodyPr wrap="square" anchor="t" lIns="0" rIns="0" tIns="0" bIns="0">
-            <a:spAutoFit/>
-          </a:bodyPr>
-          <a:lstStyle/>
-          <a:p>
-            <a:pPr algn="r">
-              <a:spcAft>
-                <a:spcPts val="0"/>
-              </a:spcAft>
-            </a:pPr>
-            <a:r>
-              <a:rPr sz="1300" b="1">
-                <a:solidFill>
-                  <a:srgbClr val="6E6455"/>
-                </a:solidFill>
-                <a:latin typeface="Segoe UI"/>
-              </a:rPr>
-              <a:t>≈ R380/mo</a:t>
-            </a:r>
-          </a:p>
-        </p:txBody>
-      </p:sp>
-      <p:sp>
-        <p:nvSpPr>
-          <p:cNvPr id="24" name="TextBox 23"/>
-          <p:cNvSpPr txBox="1"/>
-          <p:nvPr/>
-        </p:nvSpPr>
-        <p:spPr>
-          <a:xfrm>
-            <a:off x="822960" y="6172200"/>
-            <a:ext cx="10515600" cy="365760"/>
-          </a:xfrm>
-          <a:prstGeom prst="rect">
-            <a:avLst/>
-          </a:prstGeom>
-          <a:noFill/>
-        </p:spPr>
-        <p:txBody>
-          <a:bodyPr wrap="square" anchor="t" lIns="0" rIns="0" tIns="0" bIns="0">
-            <a:spAutoFit/>
-          </a:bodyPr>
-          <a:lstStyle/>
-          <a:p>
-            <a:pPr algn="l">
-              <a:spcAft>
-                <a:spcPts val="0"/>
-              </a:spcAft>
-            </a:pPr>
-            <a:r>
-              <a:rPr sz="1100" b="0">
-                <a:solidFill>
-                  <a:srgbClr val="7A7264"/>
-                </a:solidFill>
-                <a:latin typeface="Segoe UI"/>
-              </a:rPr>
-              <a:t>Figures current as of August 2026 — pricing and the Rand exchange rate will move over time.</a:t>
-            </a:r>
-          </a:p>
-        </p:txBody>
-      </p:sp>
-      <p:sp>
-        <p:nvSpPr>
-          <p:cNvPr id="25" name="TextBox 24"/>
-          <p:cNvSpPr txBox="1"/>
-          <p:nvPr/>
-        </p:nvSpPr>
-        <p:spPr>
-          <a:xfrm>
-            <a:off x="11002975" y="6291072"/>
-            <a:ext cx="640080" cy="274320"/>
-          </a:xfrm>
-          <a:prstGeom prst="rect">
-            <a:avLst/>
-          </a:prstGeom>
-          <a:noFill/>
-        </p:spPr>
-        <p:txBody>
-          <a:bodyPr wrap="square" anchor="t" lIns="0" rIns="0" tIns="0" bIns="0">
-            <a:spAutoFit/>
-          </a:bodyPr>
-          <a:lstStyle/>
-          <a:p>
-            <a:pPr algn="r">
-              <a:spcAft>
-                <a:spcPts val="0"/>
-              </a:spcAft>
-            </a:pPr>
-            <a:r>
-              <a:rPr sz="950" b="0">
-                <a:solidFill>
-                  <a:srgbClr val="7A7264"/>
-                </a:solidFill>
-                <a:latin typeface="Segoe UI"/>
-              </a:rPr>
-              <a:t>14</a:t>
-            </a:r>
-          </a:p>
-        </p:txBody>
-      </p:sp>
-    </p:spTree>
-  </p:cSld>
-  <p:clrMapOvr>
-    <a:masterClrMapping/>
-  </p:clrMapOvr>
-</p:sld>
-</file>
-
-<file path=ppt/slides/slide15.xml><?xml version="1.0" encoding="utf-8"?>
-<p:sld xmlns:a="http://schemas.openxmlformats.org/drawingml/2006/main" xmlns:p="http://schemas.openxmlformats.org/presentationml/2006/main" xmlns:r="http://schemas.openxmlformats.org/officeDocument/2006/relationships">
-  <p:cSld>
-    <p:spTree>
-      <p:nvGrpSpPr>
-        <p:cNvPr id="1" name=""/>
-        <p:cNvGrpSpPr/>
-        <p:nvPr/>
-      </p:nvGrpSpPr>
-      <p:grpSpPr/>
-      <p:sp>
-        <p:nvSpPr>
-          <p:cNvPr id="2" name="Rectangle 1"/>
-          <p:cNvSpPr/>
-          <p:nvPr/>
-        </p:nvSpPr>
-        <p:spPr>
-          <a:xfrm>
-            <a:off x="0" y="0"/>
-            <a:ext cx="12191695" cy="6858000"/>
-          </a:xfrm>
-          <a:prstGeom prst="rect">
-            <a:avLst/>
-          </a:prstGeom>
-          <a:solidFill>
-            <a:srgbClr val="FAF9F7"/>
-          </a:solidFill>
-          <a:ln>
-            <a:noFill/>
-          </a:ln>
-          <a:effectLst/>
-        </p:spPr>
-        <p:style>
-          <a:lnRef idx="1">
-            <a:schemeClr val="accent1"/>
-          </a:lnRef>
-          <a:fillRef idx="3">
-            <a:schemeClr val="accent1"/>
-          </a:fillRef>
-          <a:effectRef idx="2">
-            <a:schemeClr val="accent1"/>
-          </a:effectRef>
-          <a:fontRef idx="minor">
-            <a:schemeClr val="lt1"/>
-          </a:fontRef>
-        </p:style>
-        <p:txBody>
-          <a:bodyPr rtlCol="0" anchor="ctr"/>
-          <a:lstStyle/>
-          <a:p>
-            <a:pPr algn="ctr"/>
-          </a:p>
-        </p:txBody>
-      </p:sp>
-      <p:sp>
-        <p:nvSpPr>
-          <p:cNvPr id="3" name="TextBox 2"/>
-          <p:cNvSpPr txBox="1"/>
-          <p:nvPr/>
-        </p:nvSpPr>
-        <p:spPr>
-          <a:xfrm>
-            <a:off x="822960" y="457200"/>
-            <a:ext cx="2743200" cy="548640"/>
-          </a:xfrm>
-          <a:prstGeom prst="rect">
-            <a:avLst/>
-          </a:prstGeom>
-          <a:noFill/>
-        </p:spPr>
-        <p:txBody>
-          <a:bodyPr wrap="square" anchor="t" lIns="0" rIns="0" tIns="0" bIns="0">
-            <a:spAutoFit/>
-          </a:bodyPr>
-          <a:lstStyle/>
-          <a:p>
-            <a:r>
-              <a:rPr sz="1500">
-                <a:solidFill>
-                  <a:srgbClr val="8A7F6F"/>
-                </a:solidFill>
-                <a:latin typeface="Segoe UI Light"/>
-              </a:rPr>
-              <a:t>HAIR</a:t>
-            </a:r>
-            <a:r>
-              <a:rPr sz="1500">
-                <a:solidFill>
-                  <a:srgbClr val="1A1816"/>
-                </a:solidFill>
-                <a:latin typeface="Segoe UI Light"/>
-              </a:rPr>
-              <a:t>|</a:t>
-            </a:r>
-            <a:r>
-              <a:rPr sz="1500">
-                <a:solidFill>
-                  <a:srgbClr val="1A1816"/>
-                </a:solidFill>
-                <a:latin typeface="Segoe UI Light"/>
-              </a:rPr>
-              <a:t>line</a:t>
-            </a:r>
-          </a:p>
-        </p:txBody>
-      </p:sp>
-      <p:sp>
-        <p:nvSpPr>
-          <p:cNvPr id="4" name="TextBox 3"/>
-          <p:cNvSpPr txBox="1"/>
-          <p:nvPr/>
-        </p:nvSpPr>
-        <p:spPr>
-          <a:xfrm>
-            <a:off x="822960" y="1051560"/>
-            <a:ext cx="8229600" cy="274320"/>
-          </a:xfrm>
-          <a:prstGeom prst="rect">
-            <a:avLst/>
-          </a:prstGeom>
-          <a:noFill/>
-        </p:spPr>
-        <p:txBody>
-          <a:bodyPr wrap="square" anchor="t" lIns="0" rIns="0" tIns="0" bIns="0">
-            <a:spAutoFit/>
-          </a:bodyPr>
-          <a:lstStyle/>
-          <a:p>
-            <a:pPr algn="l">
-              <a:spcAft>
-                <a:spcPts val="0"/>
-              </a:spcAft>
-            </a:pPr>
-            <a:r>
-              <a:rPr sz="1050" b="1" spc="180">
-                <a:solidFill>
-                  <a:srgbClr val="8A7F6F"/>
-                </a:solidFill>
-                <a:latin typeface="Segoe UI"/>
-              </a:rPr>
               <a:t>OVER TO YOU</a:t>
             </a:r>
           </a:p>
@@ -8879,7 +7737,7 @@
                 </a:solidFill>
                 <a:latin typeface="Segoe UI"/>
               </a:rPr>
-              <a:t>15</a:t>
+              <a:t>14</a:t>
             </a:r>
           </a:p>
         </p:txBody>
@@ -15061,7 +13919,7 @@
                 </a:solidFill>
                 <a:latin typeface="Segoe UI"/>
               </a:rPr>
-              <a:t>Big tappable tiles</a:t>
+              <a:t>Ordered by what you sell</a:t>
             </a:r>
             <a:r>
               <a:rPr sz="1200">
@@ -15070,7 +13928,7 @@
                 </a:solidFill>
                 <a:latin typeface="Segoe UI"/>
               </a:rPr>
-              <a:t> — laid out for a counter, not a desk.</a:t>
+              <a:t> — the everyday services sit at the top.</a:t>
             </a:r>
           </a:p>
           <a:p>
@@ -15098,7 +13956,7 @@
                 </a:solidFill>
                 <a:latin typeface="Segoe UI"/>
               </a:rPr>
-              <a:t>The balance owing</a:t>
+              <a:t>A docket per client,</a:t>
             </a:r>
             <a:r>
               <a:rPr sz="1200">
@@ -15107,7 +13965,7 @@
                 </a:solidFill>
                 <a:latin typeface="Segoe UI"/>
               </a:rPr>
-              <a:t> is the largest thing on screen, with a keypad beneath it.</a:t>
+              <a:t> opened on arrival, settled at the counter.</a:t>
             </a:r>
           </a:p>
           <a:p>
@@ -15135,7 +13993,7 @@
                 </a:solidFill>
                 <a:latin typeface="Segoe UI"/>
               </a:rPr>
-              <a:t>A live timer</a:t>
+              <a:t>The balance owing</a:t>
             </a:r>
             <a:r>
               <a:rPr sz="1200">
@@ -15144,7 +14002,7 @@
                 </a:solidFill>
                 <a:latin typeface="Segoe UI"/>
               </a:rPr>
-              <a:t> keeps the 30-second target honest.</a:t>
+              <a:t> is the largest thing on screen, keypad beneath it.</a:t>
             </a:r>
           </a:p>
         </p:txBody>

</xml_diff>